<commit_message>
fix in save ft
</commit_message>
<xml_diff>
--- a/tests/tmp/merge.pptx
+++ b/tests/tmp/merge.pptx
@@ -2,10 +2,10 @@
 <file path=ppt/presentation.xml><?xml version="1.0" encoding="utf-8"?>
 <p:presentation xmlns:a="http://schemas.openxmlformats.org/drawingml/2006/main" xmlns:r="http://schemas.openxmlformats.org/officeDocument/2006/relationships" xmlns:p="http://schemas.openxmlformats.org/presentationml/2006/main" saveSubsetFonts="1">
   <p:sldMasterIdLst>
-    <p:sldMasterId id="2147483887" r:id="rId1"/>
-    <p:sldMasterId id="2147483888" r:id="rId2"/>
-    <p:sldMasterId id="2147483889" r:id="rId3"/>
-    <p:sldMasterId id="2147483890" r:id="rId4"/>
+    <p:sldMasterId id="2147483828" r:id="rId1"/>
+    <p:sldMasterId id="2147483829" r:id="rId2"/>
+    <p:sldMasterId id="2147483830" r:id="rId3"/>
+    <p:sldMasterId id="2147483831" r:id="rId4"/>
   </p:sldMasterIdLst>
   <p:sldIdLst>
     <p:sldId id="256" r:id="rId5"/>
@@ -9440,18 +9440,18 @@
   </p:cSld>
   <p:clrMap bg1="lt1" tx1="dk1" bg2="lt2" tx2="dk2" accent1="accent1" accent2="accent2" accent3="accent3" accent4="accent4" accent5="accent5" accent6="accent6" hlink="hlink" folHlink="folHlink"/>
   <p:sldLayoutIdLst>
-    <p:sldLayoutId id="2147483839" r:id="rId2"/>
-    <p:sldLayoutId id="2147483840" r:id="rId3"/>
-    <p:sldLayoutId id="2147483841" r:id="rId4"/>
-    <p:sldLayoutId id="2147483842" r:id="rId5"/>
-    <p:sldLayoutId id="2147483843" r:id="rId6"/>
-    <p:sldLayoutId id="2147483844" r:id="rId7"/>
-    <p:sldLayoutId id="2147483845" r:id="rId8"/>
-    <p:sldLayoutId id="2147483846" r:id="rId9"/>
-    <p:sldLayoutId id="2147483847" r:id="rId10"/>
-    <p:sldLayoutId id="2147483848" r:id="rId11"/>
-    <p:sldLayoutId id="2147483849" r:id="rId12"/>
-    <p:sldLayoutId id="2147483850" r:id="rId13"/>
+    <p:sldLayoutId id="2147483780" r:id="rId2"/>
+    <p:sldLayoutId id="2147483781" r:id="rId3"/>
+    <p:sldLayoutId id="2147483782" r:id="rId4"/>
+    <p:sldLayoutId id="2147483783" r:id="rId5"/>
+    <p:sldLayoutId id="2147483784" r:id="rId6"/>
+    <p:sldLayoutId id="2147483785" r:id="rId7"/>
+    <p:sldLayoutId id="2147483786" r:id="rId8"/>
+    <p:sldLayoutId id="2147483787" r:id="rId9"/>
+    <p:sldLayoutId id="2147483788" r:id="rId10"/>
+    <p:sldLayoutId id="2147483789" r:id="rId11"/>
+    <p:sldLayoutId id="2147483790" r:id="rId12"/>
+    <p:sldLayoutId id="2147483791" r:id="rId13"/>
   </p:sldLayoutIdLst>
   <p:txStyles>
     <p:titleStyle>

</xml_diff>